<commit_message>
feat: add PCI poster generation toolkit including data processing scripts and PowerPoint template support
</commit_message>
<xml_diff>
--- a/pci_poster/examples/rhyl_example.pptx
+++ b/pci_poster/examples/rhyl_example.pptx
@@ -118,13 +118,220 @@
 <file path=ppt/revisionInfo.xml><?xml version="1.0" encoding="utf-8"?>
 <p1510:revInfo xmlns:a="http://schemas.openxmlformats.org/drawingml/2006/main" xmlns:r="http://schemas.openxmlformats.org/officeDocument/2006/relationships" xmlns:p1510="http://schemas.microsoft.com/office/powerpoint/2015/10/main">
   <p1510:revLst>
-    <p1510:client id="{ED38708C-B479-4D1A-B454-6F08E9750427}" v="8" dt="2026-01-20T00:37:01.477"/>
+    <p1510:client id="{D3870EF7-B2CE-481F-8861-820EAD3EA9F1}" v="2" dt="2026-03-11T11:13:48.408"/>
   </p1510:revLst>
 </p1510:revInfo>
 </file>
 
 <file path=ppt/changesInfos/changesInfo1.xml><?xml version="1.0" encoding="utf-8"?>
 <pc:chgInfo xmlns:a="http://schemas.openxmlformats.org/drawingml/2006/main" xmlns:r="http://schemas.openxmlformats.org/officeDocument/2006/relationships" xmlns:ac="http://schemas.microsoft.com/office/drawing/2013/main/command" xmlns:pc="http://schemas.microsoft.com/office/powerpoint/2013/main/command">
+  <pc:docChgLst>
+    <pc:chgData name="Gillett, Richard" userId="f751afb3-89ee-4adb-bf46-b352b62550b4" providerId="ADAL" clId="{D3870EF7-B2CE-481F-8861-820EAD3EA9F1}"/>
+    <pc:docChg chg="custSel modSld modMainMaster">
+      <pc:chgData name="Gillett, Richard" userId="f751afb3-89ee-4adb-bf46-b352b62550b4" providerId="ADAL" clId="{D3870EF7-B2CE-481F-8861-820EAD3EA9F1}" dt="2026-03-11T11:16:03.666" v="161" actId="20577"/>
+      <pc:docMkLst>
+        <pc:docMk/>
+      </pc:docMkLst>
+      <pc:sldChg chg="modSp mod">
+        <pc:chgData name="Gillett, Richard" userId="f751afb3-89ee-4adb-bf46-b352b62550b4" providerId="ADAL" clId="{D3870EF7-B2CE-481F-8861-820EAD3EA9F1}" dt="2026-03-11T11:16:03.666" v="161" actId="20577"/>
+        <pc:sldMkLst>
+          <pc:docMk/>
+          <pc:sldMk cId="0" sldId="256"/>
+        </pc:sldMkLst>
+        <pc:spChg chg="mod">
+          <ac:chgData name="Gillett, Richard" userId="f751afb3-89ee-4adb-bf46-b352b62550b4" providerId="ADAL" clId="{D3870EF7-B2CE-481F-8861-820EAD3EA9F1}" dt="2026-03-11T11:15:00.304" v="78" actId="20577"/>
+          <ac:spMkLst>
+            <pc:docMk/>
+            <pc:sldMk cId="0" sldId="256"/>
+            <ac:spMk id="7" creationId="{00000000-0000-0000-0000-000000000000}"/>
+          </ac:spMkLst>
+        </pc:spChg>
+        <pc:spChg chg="mod">
+          <ac:chgData name="Gillett, Richard" userId="f751afb3-89ee-4adb-bf46-b352b62550b4" providerId="ADAL" clId="{D3870EF7-B2CE-481F-8861-820EAD3EA9F1}" dt="2026-03-11T11:14:31.306" v="15" actId="207"/>
+          <ac:spMkLst>
+            <pc:docMk/>
+            <pc:sldMk cId="0" sldId="256"/>
+            <ac:spMk id="8" creationId="{00000000-0000-0000-0000-000000000000}"/>
+          </ac:spMkLst>
+        </pc:spChg>
+        <pc:spChg chg="mod">
+          <ac:chgData name="Gillett, Richard" userId="f751afb3-89ee-4adb-bf46-b352b62550b4" providerId="ADAL" clId="{D3870EF7-B2CE-481F-8861-820EAD3EA9F1}" dt="2026-03-11T11:16:03.666" v="161" actId="20577"/>
+          <ac:spMkLst>
+            <pc:docMk/>
+            <pc:sldMk cId="0" sldId="256"/>
+            <ac:spMk id="11" creationId="{00000000-0000-0000-0000-000000000000}"/>
+          </ac:spMkLst>
+        </pc:spChg>
+        <pc:spChg chg="mod">
+          <ac:chgData name="Gillett, Richard" userId="f751afb3-89ee-4adb-bf46-b352b62550b4" providerId="ADAL" clId="{D3870EF7-B2CE-481F-8861-820EAD3EA9F1}" dt="2026-03-11T11:15:41.937" v="124" actId="207"/>
+          <ac:spMkLst>
+            <pc:docMk/>
+            <pc:sldMk cId="0" sldId="256"/>
+            <ac:spMk id="12" creationId="{00000000-0000-0000-0000-000000000000}"/>
+          </ac:spMkLst>
+        </pc:spChg>
+      </pc:sldChg>
+      <pc:sldMasterChg chg="modSldLayout">
+        <pc:chgData name="Gillett, Richard" userId="f751afb3-89ee-4adb-bf46-b352b62550b4" providerId="ADAL" clId="{D3870EF7-B2CE-481F-8861-820EAD3EA9F1}" dt="2026-03-11T11:13:48.408" v="2"/>
+        <pc:sldMasterMkLst>
+          <pc:docMk/>
+          <pc:sldMasterMk cId="2640799190" sldId="2147483660"/>
+        </pc:sldMasterMkLst>
+        <pc:sldLayoutChg chg="addSp delSp modSp mod">
+          <pc:chgData name="Gillett, Richard" userId="f751afb3-89ee-4adb-bf46-b352b62550b4" providerId="ADAL" clId="{D3870EF7-B2CE-481F-8861-820EAD3EA9F1}" dt="2026-03-11T11:13:48.408" v="2"/>
+          <pc:sldLayoutMkLst>
+            <pc:docMk/>
+            <pc:sldMasterMk cId="2640799190" sldId="2147483660"/>
+            <pc:sldLayoutMk cId="1363397331" sldId="2147483661"/>
+          </pc:sldLayoutMkLst>
+          <pc:spChg chg="add mod">
+            <ac:chgData name="Gillett, Richard" userId="f751afb3-89ee-4adb-bf46-b352b62550b4" providerId="ADAL" clId="{D3870EF7-B2CE-481F-8861-820EAD3EA9F1}" dt="2026-03-11T11:13:36.504" v="1"/>
+            <ac:spMkLst>
+              <pc:docMk/>
+              <pc:sldMasterMk cId="2640799190" sldId="2147483660"/>
+              <pc:sldLayoutMk cId="1363397331" sldId="2147483661"/>
+              <ac:spMk id="2" creationId="{3723FF2C-A39E-EB3B-E523-F5FEEC353A1E}"/>
+            </ac:spMkLst>
+          </pc:spChg>
+          <pc:spChg chg="add mod">
+            <ac:chgData name="Gillett, Richard" userId="f751afb3-89ee-4adb-bf46-b352b62550b4" providerId="ADAL" clId="{D3870EF7-B2CE-481F-8861-820EAD3EA9F1}" dt="2026-03-11T11:13:36.504" v="1"/>
+            <ac:spMkLst>
+              <pc:docMk/>
+              <pc:sldMasterMk cId="2640799190" sldId="2147483660"/>
+              <pc:sldLayoutMk cId="1363397331" sldId="2147483661"/>
+              <ac:spMk id="3" creationId="{2246FFC7-80A1-92CC-BEE5-482CE5FDFC10}"/>
+            </ac:spMkLst>
+          </pc:spChg>
+          <pc:spChg chg="add mod">
+            <ac:chgData name="Gillett, Richard" userId="f751afb3-89ee-4adb-bf46-b352b62550b4" providerId="ADAL" clId="{D3870EF7-B2CE-481F-8861-820EAD3EA9F1}" dt="2026-03-11T11:13:36.504" v="1"/>
+            <ac:spMkLst>
+              <pc:docMk/>
+              <pc:sldMasterMk cId="2640799190" sldId="2147483660"/>
+              <pc:sldLayoutMk cId="1363397331" sldId="2147483661"/>
+              <ac:spMk id="4" creationId="{9F27922F-9508-784E-406B-7DCCD5C252DB}"/>
+            </ac:spMkLst>
+          </pc:spChg>
+          <pc:spChg chg="add mod">
+            <ac:chgData name="Gillett, Richard" userId="f751afb3-89ee-4adb-bf46-b352b62550b4" providerId="ADAL" clId="{D3870EF7-B2CE-481F-8861-820EAD3EA9F1}" dt="2026-03-11T11:13:36.504" v="1"/>
+            <ac:spMkLst>
+              <pc:docMk/>
+              <pc:sldMasterMk cId="2640799190" sldId="2147483660"/>
+              <pc:sldLayoutMk cId="1363397331" sldId="2147483661"/>
+              <ac:spMk id="5" creationId="{C94EBEE4-289A-3C4E-B519-3FDD1D2DDD37}"/>
+            </ac:spMkLst>
+          </pc:spChg>
+          <pc:spChg chg="add mod">
+            <ac:chgData name="Gillett, Richard" userId="f751afb3-89ee-4adb-bf46-b352b62550b4" providerId="ADAL" clId="{D3870EF7-B2CE-481F-8861-820EAD3EA9F1}" dt="2026-03-11T11:13:36.504" v="1"/>
+            <ac:spMkLst>
+              <pc:docMk/>
+              <pc:sldMasterMk cId="2640799190" sldId="2147483660"/>
+              <pc:sldLayoutMk cId="1363397331" sldId="2147483661"/>
+              <ac:spMk id="6" creationId="{4E071649-D758-D48B-C624-DB7B23572563}"/>
+            </ac:spMkLst>
+          </pc:spChg>
+          <pc:spChg chg="add mod">
+            <ac:chgData name="Gillett, Richard" userId="f751afb3-89ee-4adb-bf46-b352b62550b4" providerId="ADAL" clId="{D3870EF7-B2CE-481F-8861-820EAD3EA9F1}" dt="2026-03-11T11:13:36.504" v="1"/>
+            <ac:spMkLst>
+              <pc:docMk/>
+              <pc:sldMasterMk cId="2640799190" sldId="2147483660"/>
+              <pc:sldLayoutMk cId="1363397331" sldId="2147483661"/>
+              <ac:spMk id="7" creationId="{4B8B6ACB-7AEF-38A5-D862-D034A79C91D7}"/>
+            </ac:spMkLst>
+          </pc:spChg>
+          <pc:spChg chg="del">
+            <ac:chgData name="Gillett, Richard" userId="f751afb3-89ee-4adb-bf46-b352b62550b4" providerId="ADAL" clId="{D3870EF7-B2CE-481F-8861-820EAD3EA9F1}" dt="2026-03-11T11:13:35.829" v="0" actId="478"/>
+            <ac:spMkLst>
+              <pc:docMk/>
+              <pc:sldMasterMk cId="2640799190" sldId="2147483660"/>
+              <pc:sldLayoutMk cId="1363397331" sldId="2147483661"/>
+              <ac:spMk id="18" creationId="{F398ED92-E238-6D9E-B3F0-984D6E2E8650}"/>
+            </ac:spMkLst>
+          </pc:spChg>
+          <pc:spChg chg="del">
+            <ac:chgData name="Gillett, Richard" userId="f751afb3-89ee-4adb-bf46-b352b62550b4" providerId="ADAL" clId="{D3870EF7-B2CE-481F-8861-820EAD3EA9F1}" dt="2026-03-11T11:13:35.829" v="0" actId="478"/>
+            <ac:spMkLst>
+              <pc:docMk/>
+              <pc:sldMasterMk cId="2640799190" sldId="2147483660"/>
+              <pc:sldLayoutMk cId="1363397331" sldId="2147483661"/>
+              <ac:spMk id="22" creationId="{A79E2BBB-6172-9A7B-B7D2-88173061667A}"/>
+            </ac:spMkLst>
+          </pc:spChg>
+          <pc:spChg chg="del">
+            <ac:chgData name="Gillett, Richard" userId="f751afb3-89ee-4adb-bf46-b352b62550b4" providerId="ADAL" clId="{D3870EF7-B2CE-481F-8861-820EAD3EA9F1}" dt="2026-03-11T11:13:35.829" v="0" actId="478"/>
+            <ac:spMkLst>
+              <pc:docMk/>
+              <pc:sldMasterMk cId="2640799190" sldId="2147483660"/>
+              <pc:sldLayoutMk cId="1363397331" sldId="2147483661"/>
+              <ac:spMk id="37" creationId="{814A0012-CF31-67AE-4E97-AA42CBE2A6AE}"/>
+            </ac:spMkLst>
+          </pc:spChg>
+          <pc:spChg chg="del">
+            <ac:chgData name="Gillett, Richard" userId="f751afb3-89ee-4adb-bf46-b352b62550b4" providerId="ADAL" clId="{D3870EF7-B2CE-481F-8861-820EAD3EA9F1}" dt="2026-03-11T11:13:35.829" v="0" actId="478"/>
+            <ac:spMkLst>
+              <pc:docMk/>
+              <pc:sldMasterMk cId="2640799190" sldId="2147483660"/>
+              <pc:sldLayoutMk cId="1363397331" sldId="2147483661"/>
+              <ac:spMk id="41" creationId="{D4F00C51-9060-7169-179B-F541DAFC0C7E}"/>
+            </ac:spMkLst>
+          </pc:spChg>
+          <pc:spChg chg="del">
+            <ac:chgData name="Gillett, Richard" userId="f751afb3-89ee-4adb-bf46-b352b62550b4" providerId="ADAL" clId="{D3870EF7-B2CE-481F-8861-820EAD3EA9F1}" dt="2026-03-11T11:13:35.829" v="0" actId="478"/>
+            <ac:spMkLst>
+              <pc:docMk/>
+              <pc:sldMasterMk cId="2640799190" sldId="2147483660"/>
+              <pc:sldLayoutMk cId="1363397331" sldId="2147483661"/>
+              <ac:spMk id="47" creationId="{B1F62D07-2195-698B-2714-154E4501E4EB}"/>
+            </ac:spMkLst>
+          </pc:spChg>
+          <pc:spChg chg="del">
+            <ac:chgData name="Gillett, Richard" userId="f751afb3-89ee-4adb-bf46-b352b62550b4" providerId="ADAL" clId="{D3870EF7-B2CE-481F-8861-820EAD3EA9F1}" dt="2026-03-11T11:13:35.829" v="0" actId="478"/>
+            <ac:spMkLst>
+              <pc:docMk/>
+              <pc:sldMasterMk cId="2640799190" sldId="2147483660"/>
+              <pc:sldLayoutMk cId="1363397331" sldId="2147483661"/>
+              <ac:spMk id="48" creationId="{7BD5F46B-2231-6D01-C514-F696C7DDE546}"/>
+            </ac:spMkLst>
+          </pc:spChg>
+          <pc:picChg chg="add mod">
+            <ac:chgData name="Gillett, Richard" userId="f751afb3-89ee-4adb-bf46-b352b62550b4" providerId="ADAL" clId="{D3870EF7-B2CE-481F-8861-820EAD3EA9F1}" dt="2026-03-11T11:13:36.504" v="1"/>
+            <ac:picMkLst>
+              <pc:docMk/>
+              <pc:sldMasterMk cId="2640799190" sldId="2147483660"/>
+              <pc:sldLayoutMk cId="1363397331" sldId="2147483661"/>
+              <ac:picMk id="8" creationId="{239833F4-E882-925C-420D-3DBF69AA6AED}"/>
+            </ac:picMkLst>
+          </pc:picChg>
+          <pc:picChg chg="add mod">
+            <ac:chgData name="Gillett, Richard" userId="f751afb3-89ee-4adb-bf46-b352b62550b4" providerId="ADAL" clId="{D3870EF7-B2CE-481F-8861-820EAD3EA9F1}" dt="2026-03-11T11:13:48.408" v="2"/>
+            <ac:picMkLst>
+              <pc:docMk/>
+              <pc:sldMasterMk cId="2640799190" sldId="2147483660"/>
+              <pc:sldLayoutMk cId="1363397331" sldId="2147483661"/>
+              <ac:picMk id="9" creationId="{82F6D077-AF86-CA97-756B-17452826BF08}"/>
+            </ac:picMkLst>
+          </pc:picChg>
+          <pc:picChg chg="del">
+            <ac:chgData name="Gillett, Richard" userId="f751afb3-89ee-4adb-bf46-b352b62550b4" providerId="ADAL" clId="{D3870EF7-B2CE-481F-8861-820EAD3EA9F1}" dt="2026-03-11T11:13:35.829" v="0" actId="478"/>
+            <ac:picMkLst>
+              <pc:docMk/>
+              <pc:sldMasterMk cId="2640799190" sldId="2147483660"/>
+              <pc:sldLayoutMk cId="1363397331" sldId="2147483661"/>
+              <ac:picMk id="23" creationId="{86633DA3-0DB3-C6C5-5A10-0975EDA3FCAF}"/>
+            </ac:picMkLst>
+          </pc:picChg>
+          <pc:picChg chg="del">
+            <ac:chgData name="Gillett, Richard" userId="f751afb3-89ee-4adb-bf46-b352b62550b4" providerId="ADAL" clId="{D3870EF7-B2CE-481F-8861-820EAD3EA9F1}" dt="2026-03-11T11:13:35.829" v="0" actId="478"/>
+            <ac:picMkLst>
+              <pc:docMk/>
+              <pc:sldMasterMk cId="2640799190" sldId="2147483660"/>
+              <pc:sldLayoutMk cId="1363397331" sldId="2147483661"/>
+              <ac:picMk id="94" creationId="{6C1D9F35-E879-69FC-7F97-6A6DA195BB72}"/>
+            </ac:picMkLst>
+          </pc:picChg>
+        </pc:sldLayoutChg>
+      </pc:sldMasterChg>
+    </pc:docChg>
+  </pc:docChgLst>
   <pc:docChgLst>
     <pc:chgData name="Gillett, Richard" userId="f751afb3-89ee-4adb-bf46-b352b62550b4" providerId="ADAL" clId="{A5BB3A64-C60C-45E9-BAE7-11B96E1E2D18}"/>
     <pc:docChg chg="undo custSel modMainMaster">
@@ -252,15 +459,6 @@
             </ac:spMkLst>
           </pc:spChg>
           <pc:spChg chg="mod">
-            <ac:chgData name="Gillett, Richard" userId="f751afb3-89ee-4adb-bf46-b352b62550b4" providerId="ADAL" clId="{A5BB3A64-C60C-45E9-BAE7-11B96E1E2D18}" dt="2026-01-14T04:45:07.872" v="47" actId="1076"/>
-            <ac:spMkLst>
-              <pc:docMk/>
-              <pc:sldMasterMk cId="2640799190" sldId="2147483660"/>
-              <pc:sldLayoutMk cId="1363397331" sldId="2147483661"/>
-              <ac:spMk id="22" creationId="{A79E2BBB-6172-9A7B-B7D2-88173061667A}"/>
-            </ac:spMkLst>
-          </pc:spChg>
-          <pc:spChg chg="mod">
             <ac:chgData name="Gillett, Richard" userId="f751afb3-89ee-4adb-bf46-b352b62550b4" providerId="ADAL" clId="{A5BB3A64-C60C-45E9-BAE7-11B96E1E2D18}" dt="2026-01-14T04:43:22.291" v="17" actId="14100"/>
             <ac:spMkLst>
               <pc:docMk/>
@@ -276,15 +474,6 @@
               <pc:sldMasterMk cId="2640799190" sldId="2147483660"/>
               <pc:sldLayoutMk cId="1363397331" sldId="2147483661"/>
               <ac:spMk id="40" creationId="{3AAC2047-1448-EBFC-6433-602F17048C37}"/>
-            </ac:spMkLst>
-          </pc:spChg>
-          <pc:spChg chg="mod">
-            <ac:chgData name="Gillett, Richard" userId="f751afb3-89ee-4adb-bf46-b352b62550b4" providerId="ADAL" clId="{A5BB3A64-C60C-45E9-BAE7-11B96E1E2D18}" dt="2026-01-14T04:45:15.163" v="49" actId="14100"/>
-            <ac:spMkLst>
-              <pc:docMk/>
-              <pc:sldMasterMk cId="2640799190" sldId="2147483660"/>
-              <pc:sldLayoutMk cId="1363397331" sldId="2147483661"/>
-              <ac:spMk id="41" creationId="{D4F00C51-9060-7169-179B-F541DAFC0C7E}"/>
             </ac:spMkLst>
           </pc:spChg>
           <pc:spChg chg="mod">
@@ -306,15 +495,6 @@
             </ac:spMkLst>
           </pc:spChg>
           <pc:spChg chg="mod">
-            <ac:chgData name="Gillett, Richard" userId="f751afb3-89ee-4adb-bf46-b352b62550b4" providerId="ADAL" clId="{A5BB3A64-C60C-45E9-BAE7-11B96E1E2D18}" dt="2026-01-14T04:44:57.124" v="46" actId="1076"/>
-            <ac:spMkLst>
-              <pc:docMk/>
-              <pc:sldMasterMk cId="2640799190" sldId="2147483660"/>
-              <pc:sldLayoutMk cId="1363397331" sldId="2147483661"/>
-              <ac:spMk id="47" creationId="{B1F62D07-2195-698B-2714-154E4501E4EB}"/>
-            </ac:spMkLst>
-          </pc:spChg>
-          <pc:spChg chg="mod">
             <ac:chgData name="Gillett, Richard" userId="f751afb3-89ee-4adb-bf46-b352b62550b4" providerId="ADAL" clId="{A5BB3A64-C60C-45E9-BAE7-11B96E1E2D18}" dt="2026-01-14T04:43:14.725" v="15" actId="1037"/>
             <ac:spMkLst>
               <pc:docMk/>
@@ -332,15 +512,6 @@
               <ac:spMk id="50" creationId="{A8C0D454-B653-61F4-5751-F6813F0ADF7C}"/>
             </ac:spMkLst>
           </pc:spChg>
-          <pc:picChg chg="mod">
-            <ac:chgData name="Gillett, Richard" userId="f751afb3-89ee-4adb-bf46-b352b62550b4" providerId="ADAL" clId="{A5BB3A64-C60C-45E9-BAE7-11B96E1E2D18}" dt="2026-01-14T04:45:07.872" v="47" actId="1076"/>
-            <ac:picMkLst>
-              <pc:docMk/>
-              <pc:sldMasterMk cId="2640799190" sldId="2147483660"/>
-              <pc:sldLayoutMk cId="1363397331" sldId="2147483661"/>
-              <ac:picMk id="94" creationId="{6C1D9F35-E879-69FC-7F97-6A6DA195BB72}"/>
-            </ac:picMkLst>
-          </pc:picChg>
           <pc:picChg chg="mod">
             <ac:chgData name="Gillett, Richard" userId="f751afb3-89ee-4adb-bf46-b352b62550b4" providerId="ADAL" clId="{A5BB3A64-C60C-45E9-BAE7-11B96E1E2D18}" dt="2026-01-14T04:46:38.410" v="60" actId="1076"/>
             <ac:picMkLst>
@@ -681,15 +852,6 @@
               <ac:spMk id="17" creationId="{E153B05D-1487-8051-2ADA-5CCDC9A62160}"/>
             </ac:spMkLst>
           </pc:spChg>
-          <pc:spChg chg="add mod">
-            <ac:chgData name="Gillett, Richard" userId="f751afb3-89ee-4adb-bf46-b352b62550b4" providerId="ADAL" clId="{E1DC7D8A-5337-4AAE-9935-D0A80B248513}" dt="2026-01-11T11:56:31.392" v="896" actId="1076"/>
-            <ac:spMkLst>
-              <pc:docMk/>
-              <pc:sldMasterMk cId="2640799190" sldId="2147483660"/>
-              <pc:sldLayoutMk cId="1363397331" sldId="2147483661"/>
-              <ac:spMk id="18" creationId="{F398ED92-E238-6D9E-B3F0-984D6E2E8650}"/>
-            </ac:spMkLst>
-          </pc:spChg>
           <pc:spChg chg="mod">
             <ac:chgData name="Gillett, Richard" userId="f751afb3-89ee-4adb-bf46-b352b62550b4" providerId="ADAL" clId="{E1DC7D8A-5337-4AAE-9935-D0A80B248513}" dt="2026-01-10T14:21:05.082" v="891" actId="207"/>
             <ac:spMkLst>
@@ -706,24 +868,6 @@
               <pc:sldMasterMk cId="2640799190" sldId="2147483660"/>
               <pc:sldLayoutMk cId="1363397331" sldId="2147483661"/>
               <ac:spMk id="21" creationId="{8E7B100D-340E-CDEA-8F6B-7FDE741C252A}"/>
-            </ac:spMkLst>
-          </pc:spChg>
-          <pc:spChg chg="mod">
-            <ac:chgData name="Gillett, Richard" userId="f751afb3-89ee-4adb-bf46-b352b62550b4" providerId="ADAL" clId="{E1DC7D8A-5337-4AAE-9935-D0A80B248513}" dt="2026-01-11T11:57:10.271" v="901" actId="1076"/>
-            <ac:spMkLst>
-              <pc:docMk/>
-              <pc:sldMasterMk cId="2640799190" sldId="2147483660"/>
-              <pc:sldLayoutMk cId="1363397331" sldId="2147483661"/>
-              <ac:spMk id="22" creationId="{A79E2BBB-6172-9A7B-B7D2-88173061667A}"/>
-            </ac:spMkLst>
-          </pc:spChg>
-          <pc:spChg chg="mod">
-            <ac:chgData name="Gillett, Richard" userId="f751afb3-89ee-4adb-bf46-b352b62550b4" providerId="ADAL" clId="{E1DC7D8A-5337-4AAE-9935-D0A80B248513}" dt="2026-01-11T11:56:53.889" v="900" actId="14100"/>
-            <ac:spMkLst>
-              <pc:docMk/>
-              <pc:sldMasterMk cId="2640799190" sldId="2147483660"/>
-              <pc:sldLayoutMk cId="1363397331" sldId="2147483661"/>
-              <ac:spMk id="37" creationId="{814A0012-CF31-67AE-4E97-AA42CBE2A6AE}"/>
             </ac:spMkLst>
           </pc:spChg>
           <pc:spChg chg="add mod">
@@ -751,15 +895,6 @@
               <pc:sldMasterMk cId="2640799190" sldId="2147483660"/>
               <pc:sldLayoutMk cId="1363397331" sldId="2147483661"/>
               <ac:spMk id="40" creationId="{3AAC2047-1448-EBFC-6433-602F17048C37}"/>
-            </ac:spMkLst>
-          </pc:spChg>
-          <pc:spChg chg="mod">
-            <ac:chgData name="Gillett, Richard" userId="f751afb3-89ee-4adb-bf46-b352b62550b4" providerId="ADAL" clId="{E1DC7D8A-5337-4AAE-9935-D0A80B248513}" dt="2026-01-11T11:57:10.271" v="901" actId="1076"/>
-            <ac:spMkLst>
-              <pc:docMk/>
-              <pc:sldMasterMk cId="2640799190" sldId="2147483660"/>
-              <pc:sldLayoutMk cId="1363397331" sldId="2147483661"/>
-              <ac:spMk id="41" creationId="{D4F00C51-9060-7169-179B-F541DAFC0C7E}"/>
             </ac:spMkLst>
           </pc:spChg>
           <pc:spChg chg="add mod">
@@ -796,24 +931,6 @@
               <pc:sldMasterMk cId="2640799190" sldId="2147483660"/>
               <pc:sldLayoutMk cId="1363397331" sldId="2147483661"/>
               <ac:spMk id="46" creationId="{6C6C5E27-B920-6468-D3D0-CF1BF1645A0B}"/>
-            </ac:spMkLst>
-          </pc:spChg>
-          <pc:spChg chg="mod">
-            <ac:chgData name="Gillett, Richard" userId="f751afb3-89ee-4adb-bf46-b352b62550b4" providerId="ADAL" clId="{E1DC7D8A-5337-4AAE-9935-D0A80B248513}" dt="2026-01-11T11:57:10.271" v="901" actId="1076"/>
-            <ac:spMkLst>
-              <pc:docMk/>
-              <pc:sldMasterMk cId="2640799190" sldId="2147483660"/>
-              <pc:sldLayoutMk cId="1363397331" sldId="2147483661"/>
-              <ac:spMk id="47" creationId="{B1F62D07-2195-698B-2714-154E4501E4EB}"/>
-            </ac:spMkLst>
-          </pc:spChg>
-          <pc:spChg chg="add mod">
-            <ac:chgData name="Gillett, Richard" userId="f751afb3-89ee-4adb-bf46-b352b62550b4" providerId="ADAL" clId="{E1DC7D8A-5337-4AAE-9935-D0A80B248513}" dt="2026-01-11T11:57:21.551" v="902" actId="1076"/>
-            <ac:spMkLst>
-              <pc:docMk/>
-              <pc:sldMasterMk cId="2640799190" sldId="2147483660"/>
-              <pc:sldLayoutMk cId="1363397331" sldId="2147483661"/>
-              <ac:spMk id="48" creationId="{7BD5F46B-2231-6D01-C514-F696C7DDE546}"/>
             </ac:spMkLst>
           </pc:spChg>
           <pc:spChg chg="mod">
@@ -871,15 +988,6 @@
             </ac:picMkLst>
           </pc:picChg>
           <pc:picChg chg="mod">
-            <ac:chgData name="Gillett, Richard" userId="f751afb3-89ee-4adb-bf46-b352b62550b4" providerId="ADAL" clId="{E1DC7D8A-5337-4AAE-9935-D0A80B248513}" dt="2026-01-11T11:56:31.392" v="896" actId="1076"/>
-            <ac:picMkLst>
-              <pc:docMk/>
-              <pc:sldMasterMk cId="2640799190" sldId="2147483660"/>
-              <pc:sldLayoutMk cId="1363397331" sldId="2147483661"/>
-              <ac:picMk id="23" creationId="{86633DA3-0DB3-C6C5-5A10-0975EDA3FCAF}"/>
-            </ac:picMkLst>
-          </pc:picChg>
-          <pc:picChg chg="mod">
             <ac:chgData name="Gillett, Richard" userId="f751afb3-89ee-4adb-bf46-b352b62550b4" providerId="ADAL" clId="{E1DC7D8A-5337-4AAE-9935-D0A80B248513}" dt="2026-01-10T11:49:48.696" v="648" actId="1038"/>
             <ac:picMkLst>
               <pc:docMk/>
@@ -895,15 +1003,6 @@
               <pc:sldMasterMk cId="2640799190" sldId="2147483660"/>
               <pc:sldLayoutMk cId="1363397331" sldId="2147483661"/>
               <ac:picMk id="53" creationId="{02E5031A-50D3-880E-59DE-415DAA829CAC}"/>
-            </ac:picMkLst>
-          </pc:picChg>
-          <pc:picChg chg="mod">
-            <ac:chgData name="Gillett, Richard" userId="f751afb3-89ee-4adb-bf46-b352b62550b4" providerId="ADAL" clId="{E1DC7D8A-5337-4AAE-9935-D0A80B248513}" dt="2026-01-11T11:57:10.271" v="901" actId="1076"/>
-            <ac:picMkLst>
-              <pc:docMk/>
-              <pc:sldMasterMk cId="2640799190" sldId="2147483660"/>
-              <pc:sldLayoutMk cId="1363397331" sldId="2147483661"/>
-              <ac:picMk id="94" creationId="{6C1D9F35-E879-69FC-7F97-6A6DA195BB72}"/>
             </ac:picMkLst>
           </pc:picChg>
           <pc:picChg chg="add mod ord modCrop">
@@ -924,15 +1023,6 @@
               <ac:picMk id="2075" creationId="{541A6AC7-D175-3548-67FC-DC5600EFAB59}"/>
             </ac:picMkLst>
           </pc:picChg>
-          <pc:cxnChg chg="mod">
-            <ac:chgData name="Gillett, Richard" userId="f751afb3-89ee-4adb-bf46-b352b62550b4" providerId="ADAL" clId="{E1DC7D8A-5337-4AAE-9935-D0A80B248513}" dt="2026-01-11T11:57:10.271" v="901" actId="1076"/>
-            <ac:cxnSpMkLst>
-              <pc:docMk/>
-              <pc:sldMasterMk cId="2640799190" sldId="2147483660"/>
-              <pc:sldLayoutMk cId="1363397331" sldId="2147483661"/>
-              <ac:cxnSpMk id="4" creationId="{5BB082F5-DE58-9BB3-E67C-CBAE81B32259}"/>
-            </ac:cxnSpMkLst>
-          </pc:cxnChg>
         </pc:sldLayoutChg>
         <pc:sldLayoutChg chg="addSp delSp modSp mod">
           <pc:chgData name="Gillett, Richard" userId="f751afb3-89ee-4adb-bf46-b352b62550b4" providerId="ADAL" clId="{E1DC7D8A-5337-4AAE-9935-D0A80B248513}" dt="2026-01-08T00:11:34.439" v="311" actId="21"/>
@@ -1043,12 +1133,12 @@
   <pc:docChgLst>
     <pc:chgData name="Gillett, Richard" userId="f751afb3-89ee-4adb-bf46-b352b62550b4" providerId="ADAL" clId="{ED38708C-B479-4D1A-B454-6F08E9750427}"/>
     <pc:docChg chg="undo custSel modSld modMainMaster">
-      <pc:chgData name="Gillett, Richard" userId="f751afb3-89ee-4adb-bf46-b352b62550b4" providerId="ADAL" clId="{ED38708C-B479-4D1A-B454-6F08E9750427}" dt="2026-01-21T06:41:56.161" v="148" actId="20577"/>
+      <pc:chgData name="Gillett, Richard" userId="f751afb3-89ee-4adb-bf46-b352b62550b4" providerId="ADAL" clId="{ED38708C-B479-4D1A-B454-6F08E9750427}" dt="2026-01-28T07:19:08.734" v="195" actId="478"/>
       <pc:docMkLst>
         <pc:docMk/>
       </pc:docMkLst>
       <pc:sldChg chg="addSp delSp modSp mod">
-        <pc:chgData name="Gillett, Richard" userId="f751afb3-89ee-4adb-bf46-b352b62550b4" providerId="ADAL" clId="{ED38708C-B479-4D1A-B454-6F08E9750427}" dt="2026-01-21T06:41:56.161" v="148" actId="20577"/>
+        <pc:chgData name="Gillett, Richard" userId="f751afb3-89ee-4adb-bf46-b352b62550b4" providerId="ADAL" clId="{ED38708C-B479-4D1A-B454-6F08E9750427}" dt="2026-01-28T07:18:37.561" v="185" actId="1036"/>
         <pc:sldMkLst>
           <pc:docMk/>
           <pc:sldMk cId="0" sldId="256"/>
@@ -1070,7 +1160,7 @@
           </ac:spMkLst>
         </pc:spChg>
         <pc:picChg chg="add mod">
-          <ac:chgData name="Gillett, Richard" userId="f751afb3-89ee-4adb-bf46-b352b62550b4" providerId="ADAL" clId="{ED38708C-B479-4D1A-B454-6F08E9750427}" dt="2026-01-14T06:12:23.150" v="4"/>
+          <ac:chgData name="Gillett, Richard" userId="f751afb3-89ee-4adb-bf46-b352b62550b4" providerId="ADAL" clId="{ED38708C-B479-4D1A-B454-6F08E9750427}" dt="2026-01-28T07:18:37.561" v="185" actId="1036"/>
           <ac:picMkLst>
             <pc:docMk/>
             <pc:sldMk cId="0" sldId="256"/>
@@ -1078,20 +1168,28 @@
           </ac:picMkLst>
         </pc:picChg>
       </pc:sldChg>
-      <pc:sldMasterChg chg="addSp delSp modSp mod">
-        <pc:chgData name="Gillett, Richard" userId="f751afb3-89ee-4adb-bf46-b352b62550b4" providerId="ADAL" clId="{ED38708C-B479-4D1A-B454-6F08E9750427}" dt="2026-01-20T00:37:01.477" v="99"/>
+      <pc:sldMasterChg chg="addSp delSp modSp mod modSldLayout">
+        <pc:chgData name="Gillett, Richard" userId="f751afb3-89ee-4adb-bf46-b352b62550b4" providerId="ADAL" clId="{ED38708C-B479-4D1A-B454-6F08E9750427}" dt="2026-01-28T07:19:08.734" v="195" actId="478"/>
         <pc:sldMasterMkLst>
           <pc:docMk/>
           <pc:sldMasterMk cId="2640799190" sldId="2147483660"/>
         </pc:sldMasterMkLst>
-        <pc:picChg chg="del mod">
-          <ac:chgData name="Gillett, Richard" userId="f751afb3-89ee-4adb-bf46-b352b62550b4" providerId="ADAL" clId="{ED38708C-B479-4D1A-B454-6F08E9750427}" dt="2026-01-20T00:37:00.594" v="98" actId="478"/>
-          <ac:picMkLst>
+        <pc:spChg chg="mod">
+          <ac:chgData name="Gillett, Richard" userId="f751afb3-89ee-4adb-bf46-b352b62550b4" providerId="ADAL" clId="{ED38708C-B479-4D1A-B454-6F08E9750427}" dt="2026-01-28T07:18:50.201" v="194" actId="1035"/>
+          <ac:spMkLst>
             <pc:docMk/>
             <pc:sldMasterMk cId="2640799190" sldId="2147483660"/>
-            <ac:picMk id="4" creationId="{51E7BF01-DAA0-96B3-CBE2-33C489A3AC33}"/>
-          </ac:picMkLst>
-        </pc:picChg>
+            <ac:spMk id="2" creationId="{90655420-6EA9-5F63-7C35-D9F4AC476BF3}"/>
+          </ac:spMkLst>
+        </pc:spChg>
+        <pc:grpChg chg="mod">
+          <ac:chgData name="Gillett, Richard" userId="f751afb3-89ee-4adb-bf46-b352b62550b4" providerId="ADAL" clId="{ED38708C-B479-4D1A-B454-6F08E9750427}" dt="2026-01-28T07:18:50.201" v="194" actId="1035"/>
+          <ac:grpSpMkLst>
+            <pc:docMk/>
+            <pc:sldMasterMk cId="2640799190" sldId="2147483660"/>
+            <ac:grpSpMk id="3" creationId="{8DD6D3AA-4BA7-8A63-733C-C14EAA9FDEB7}"/>
+          </ac:grpSpMkLst>
+        </pc:grpChg>
         <pc:picChg chg="add mod">
           <ac:chgData name="Gillett, Richard" userId="f751afb3-89ee-4adb-bf46-b352b62550b4" providerId="ADAL" clId="{ED38708C-B479-4D1A-B454-6F08E9750427}" dt="2026-01-20T00:37:01.477" v="99"/>
           <ac:picMkLst>
@@ -1100,6 +1198,14 @@
             <ac:picMk id="15" creationId="{806BE829-6A1A-8D00-7222-D9C28C865B74}"/>
           </ac:picMkLst>
         </pc:picChg>
+        <pc:sldLayoutChg chg="delSp mod">
+          <pc:chgData name="Gillett, Richard" userId="f751afb3-89ee-4adb-bf46-b352b62550b4" providerId="ADAL" clId="{ED38708C-B479-4D1A-B454-6F08E9750427}" dt="2026-01-28T07:19:08.734" v="195" actId="478"/>
+          <pc:sldLayoutMkLst>
+            <pc:docMk/>
+            <pc:sldMasterMk cId="2640799190" sldId="2147483660"/>
+            <pc:sldLayoutMk cId="1363397331" sldId="2147483661"/>
+          </pc:sldLayoutMkLst>
+        </pc:sldLayoutChg>
       </pc:sldMasterChg>
     </pc:docChg>
   </pc:docChgLst>
@@ -1220,7 +1326,7 @@
           <a:p>
             <a:fld id="{A88EC6AA-0CBD-4933-9AB1-52FDEFF44D8D}" type="datetimeFigureOut">
               <a:rPr lang="en-AU" smtClean="0"/>
-              <a:t>21/01/2026</a:t>
+              <a:t>11/03/2026</a:t>
             </a:fld>
             <a:endParaRPr lang="en-AU"/>
           </a:p>
@@ -1505,51 +1611,6 @@
           <a:chExt cx="0" cy="0"/>
         </a:xfrm>
       </p:grpSpPr>
-      <p:cxnSp>
-        <p:nvCxnSpPr>
-          <p:cNvPr id="4" name="steth_stem">
-            <a:extLst>
-              <a:ext uri="{FF2B5EF4-FFF2-40B4-BE49-F238E27FC236}">
-                <a16:creationId xmlns:a16="http://schemas.microsoft.com/office/drawing/2014/main" id="{5BB082F5-DE58-9BB3-E67C-CBAE81B32259}"/>
-              </a:ext>
-            </a:extLst>
-          </p:cNvPr>
-          <p:cNvCxnSpPr>
-            <a:cxnSpLocks/>
-          </p:cNvCxnSpPr>
-          <p:nvPr userDrawn="1"/>
-        </p:nvCxnSpPr>
-        <p:spPr>
-          <a:xfrm>
-            <a:off x="65965" y="8691366"/>
-            <a:ext cx="1852" cy="330402"/>
-          </a:xfrm>
-          <a:prstGeom prst="line">
-            <a:avLst/>
-          </a:prstGeom>
-          <a:ln w="76200">
-            <a:solidFill>
-              <a:schemeClr val="bg1">
-                <a:lumMod val="65000"/>
-              </a:schemeClr>
-            </a:solidFill>
-          </a:ln>
-        </p:spPr>
-        <p:style>
-          <a:lnRef idx="1">
-            <a:schemeClr val="accent1"/>
-          </a:lnRef>
-          <a:fillRef idx="0">
-            <a:schemeClr val="accent1"/>
-          </a:fillRef>
-          <a:effectRef idx="0">
-            <a:schemeClr val="accent1"/>
-          </a:effectRef>
-          <a:fontRef idx="minor">
-            <a:schemeClr val="tx1"/>
-          </a:fontRef>
-        </p:style>
-      </p:cxnSp>
       <p:sp>
         <p:nvSpPr>
           <p:cNvPr id="15" name="shp_circle_yellow">
@@ -1628,65 +1689,6 @@
           </a:prstGeom>
           <a:solidFill>
             <a:srgbClr val="00B050"/>
-          </a:solidFill>
-          <a:ln>
-            <a:noFill/>
-          </a:ln>
-        </p:spPr>
-        <p:style>
-          <a:lnRef idx="2">
-            <a:schemeClr val="accent1">
-              <a:shade val="50000"/>
-            </a:schemeClr>
-          </a:lnRef>
-          <a:fillRef idx="1">
-            <a:schemeClr val="accent1"/>
-          </a:fillRef>
-          <a:effectRef idx="0">
-            <a:schemeClr val="accent1"/>
-          </a:effectRef>
-          <a:fontRef idx="minor">
-            <a:schemeClr val="lt1"/>
-          </a:fontRef>
-        </p:style>
-        <p:txBody>
-          <a:bodyPr rtlCol="0" anchor="ctr"/>
-          <a:lstStyle/>
-          <a:p>
-            <a:pPr algn="ctr"/>
-            <a:endParaRPr lang="en-AU" sz="1801">
-              <a:solidFill>
-                <a:schemeClr val="accent1"/>
-              </a:solidFill>
-            </a:endParaRPr>
-          </a:p>
-        </p:txBody>
-      </p:sp>
-      <p:sp>
-        <p:nvSpPr>
-          <p:cNvPr id="18" name="shp_mort">
-            <a:extLst>
-              <a:ext uri="{FF2B5EF4-FFF2-40B4-BE49-F238E27FC236}">
-                <a16:creationId xmlns:a16="http://schemas.microsoft.com/office/drawing/2014/main" id="{F398ED92-E238-6D9E-B3F0-984D6E2E8650}"/>
-              </a:ext>
-            </a:extLst>
-          </p:cNvPr>
-          <p:cNvSpPr/>
-          <p:nvPr userDrawn="1"/>
-        </p:nvSpPr>
-        <p:spPr>
-          <a:xfrm>
-            <a:off x="4832549" y="4969171"/>
-            <a:ext cx="900000" cy="900000"/>
-          </a:xfrm>
-          <a:prstGeom prst="ellipse">
-            <a:avLst/>
-          </a:prstGeom>
-          <a:solidFill>
-            <a:schemeClr val="accent5">
-              <a:lumMod val="60000"/>
-              <a:lumOff val="40000"/>
-            </a:schemeClr>
           </a:solidFill>
           <a:ln>
             <a:noFill/>
@@ -1833,62 +1835,6 @@
           </a:p>
         </p:txBody>
       </p:sp>
-      <p:sp>
-        <p:nvSpPr>
-          <p:cNvPr id="22" name="shp_frailty">
-            <a:extLst>
-              <a:ext uri="{FF2B5EF4-FFF2-40B4-BE49-F238E27FC236}">
-                <a16:creationId xmlns:a16="http://schemas.microsoft.com/office/drawing/2014/main" id="{A79E2BBB-6172-9A7B-B7D2-88173061667A}"/>
-              </a:ext>
-            </a:extLst>
-          </p:cNvPr>
-          <p:cNvSpPr/>
-          <p:nvPr userDrawn="1"/>
-        </p:nvSpPr>
-        <p:spPr>
-          <a:xfrm>
-            <a:off x="3911092" y="2786713"/>
-            <a:ext cx="900000" cy="900000"/>
-          </a:xfrm>
-          <a:prstGeom prst="ellipse">
-            <a:avLst/>
-          </a:prstGeom>
-          <a:solidFill>
-            <a:schemeClr val="accent1"/>
-          </a:solidFill>
-          <a:ln>
-            <a:noFill/>
-          </a:ln>
-        </p:spPr>
-        <p:style>
-          <a:lnRef idx="2">
-            <a:schemeClr val="accent1">
-              <a:shade val="50000"/>
-            </a:schemeClr>
-          </a:lnRef>
-          <a:fillRef idx="1">
-            <a:schemeClr val="accent1"/>
-          </a:fillRef>
-          <a:effectRef idx="0">
-            <a:schemeClr val="accent1"/>
-          </a:effectRef>
-          <a:fontRef idx="minor">
-            <a:schemeClr val="lt1"/>
-          </a:fontRef>
-        </p:style>
-        <p:txBody>
-          <a:bodyPr rtlCol="0" anchor="ctr"/>
-          <a:lstStyle/>
-          <a:p>
-            <a:pPr algn="ctr"/>
-            <a:endParaRPr lang="en-AU" sz="1801" dirty="0">
-              <a:solidFill>
-                <a:schemeClr val="accent1"/>
-              </a:solidFill>
-            </a:endParaRPr>
-          </a:p>
-        </p:txBody>
-      </p:sp>
       <p:pic>
         <p:nvPicPr>
           <p:cNvPr id="53" name="pic_heart" descr="A diagram of a human heart">
@@ -1948,36 +1894,6 @@
       </p:pic>
       <p:pic>
         <p:nvPicPr>
-          <p:cNvPr id="23" name="pic_mort">
-            <a:extLst>
-              <a:ext uri="{FF2B5EF4-FFF2-40B4-BE49-F238E27FC236}">
-                <a16:creationId xmlns:a16="http://schemas.microsoft.com/office/drawing/2014/main" id="{86633DA3-0DB3-C6C5-5A10-0975EDA3FCAF}"/>
-              </a:ext>
-            </a:extLst>
-          </p:cNvPr>
-          <p:cNvPicPr>
-            <a:picLocks noChangeAspect="1"/>
-          </p:cNvPicPr>
-          <p:nvPr userDrawn="1"/>
-        </p:nvPicPr>
-        <p:blipFill>
-          <a:blip r:embed="rId4"/>
-          <a:stretch>
-            <a:fillRect/>
-          </a:stretch>
-        </p:blipFill>
-        <p:spPr>
-          <a:xfrm>
-            <a:off x="4936234" y="5043276"/>
-            <a:ext cx="587295" cy="769077"/>
-          </a:xfrm>
-          <a:prstGeom prst="rect">
-            <a:avLst/>
-          </a:prstGeom>
-        </p:spPr>
-      </p:pic>
-      <p:pic>
-        <p:nvPicPr>
           <p:cNvPr id="14" name="pic_pci">
             <a:extLst>
               <a:ext uri="{FF2B5EF4-FFF2-40B4-BE49-F238E27FC236}">
@@ -1991,11 +1907,11 @@
           <p:nvPr userDrawn="1"/>
         </p:nvPicPr>
         <p:blipFill>
-          <a:blip r:embed="rId5" cstate="print">
+          <a:blip r:embed="rId4" cstate="print">
             <a:extLst>
               <a:ext uri="{BEBA8EAE-BF5A-486C-A8C5-ECC9F3942E4B}">
                 <a14:imgProps xmlns:a14="http://schemas.microsoft.com/office/drawing/2010/main">
-                  <a14:imgLayer r:embed="rId6">
+                  <a14:imgLayer r:embed="rId5">
                     <a14:imgEffect>
                       <a14:backgroundRemoval t="10000" b="90000" l="10000" r="90000"/>
                     </a14:imgEffect>
@@ -2036,7 +1952,7 @@
           <p:nvPr userDrawn="1"/>
         </p:nvPicPr>
         <p:blipFill>
-          <a:blip r:embed="rId7" cstate="print">
+          <a:blip r:embed="rId6" cstate="print">
             <a:extLst>
               <a:ext uri="{28A0092B-C50C-407E-A947-70E740481C1C}">
                 <a14:useLocalDpi xmlns:a14="http://schemas.microsoft.com/office/drawing/2010/main"/>
@@ -2072,7 +1988,7 @@
           <p:nvPr userDrawn="1"/>
         </p:nvPicPr>
         <p:blipFill>
-          <a:blip r:embed="rId8" cstate="print">
+          <a:blip r:embed="rId7" cstate="print">
             <a:extLst>
               <a:ext uri="{28A0092B-C50C-407E-A947-70E740481C1C}">
                 <a14:useLocalDpi xmlns:a14="http://schemas.microsoft.com/office/drawing/2010/main"/>
@@ -2119,11 +2035,11 @@
           <p:nvPr userDrawn="1"/>
         </p:nvPicPr>
         <p:blipFill>
-          <a:blip r:embed="rId9" cstate="print">
+          <a:blip r:embed="rId8" cstate="print">
             <a:extLst>
               <a:ext uri="{BEBA8EAE-BF5A-486C-A8C5-ECC9F3942E4B}">
                 <a14:imgProps xmlns:a14="http://schemas.microsoft.com/office/drawing/2010/main">
-                  <a14:imgLayer r:embed="rId10">
+                  <a14:imgLayer r:embed="rId9">
                     <a14:imgEffect>
                       <a14:backgroundRemoval t="9020" b="95686" l="10000" r="89767">
                         <a14:foregroundMark x1="28837" y1="9804" x2="44651" y2="9804"/>
@@ -2157,48 +2073,6 @@
           </a:prstGeom>
         </p:spPr>
       </p:pic>
-      <p:sp>
-        <p:nvSpPr>
-          <p:cNvPr id="37" name="ph_mort30r">
-            <a:extLst>
-              <a:ext uri="{FF2B5EF4-FFF2-40B4-BE49-F238E27FC236}">
-                <a16:creationId xmlns:a16="http://schemas.microsoft.com/office/drawing/2014/main" id="{814A0012-CF31-67AE-4E97-AA42CBE2A6AE}"/>
-              </a:ext>
-            </a:extLst>
-          </p:cNvPr>
-          <p:cNvSpPr>
-            <a:spLocks noGrp="1"/>
-          </p:cNvSpPr>
-          <p:nvPr>
-            <p:ph type="body" sz="quarter" idx="12" hasCustomPrompt="1"/>
-          </p:nvPr>
-        </p:nvSpPr>
-        <p:spPr>
-          <a:xfrm>
-            <a:off x="4949781" y="5997264"/>
-            <a:ext cx="1839649" cy="620712"/>
-          </a:xfrm>
-          <a:prstGeom prst="rect">
-            <a:avLst/>
-          </a:prstGeom>
-        </p:spPr>
-        <p:txBody>
-          <a:bodyPr lIns="0" tIns="0" rIns="0" bIns="0"/>
-          <a:lstStyle>
-            <a:lvl1pPr marL="0" indent="0">
-              <a:buNone/>
-              <a:defRPr sz="1200"/>
-            </a:lvl1pPr>
-          </a:lstStyle>
-          <a:p>
-            <a:pPr lvl="0"/>
-            <a:r>
-              <a:rPr lang="en-AU" dirty="0"/>
-              <a:t>Template text here</a:t>
-            </a:r>
-          </a:p>
-        </p:txBody>
-      </p:sp>
       <p:sp>
         <p:nvSpPr>
           <p:cNvPr id="38" name="ph_postop_critical_care">
@@ -2312,48 +2186,6 @@
           <a:bodyPr lIns="0" tIns="0" rIns="0" bIns="0"/>
           <a:lstStyle>
             <a:lvl1pPr marL="0" indent="0" algn="r">
-              <a:buNone/>
-              <a:defRPr sz="1200"/>
-            </a:lvl1pPr>
-          </a:lstStyle>
-          <a:p>
-            <a:pPr lvl="0"/>
-            <a:r>
-              <a:rPr lang="en-AU" dirty="0"/>
-              <a:t>Template text here</a:t>
-            </a:r>
-          </a:p>
-        </p:txBody>
-      </p:sp>
-      <p:sp>
-        <p:nvSpPr>
-          <p:cNvPr id="41" name="ph_ihbl">
-            <a:extLst>
-              <a:ext uri="{FF2B5EF4-FFF2-40B4-BE49-F238E27FC236}">
-                <a16:creationId xmlns:a16="http://schemas.microsoft.com/office/drawing/2014/main" id="{D4F00C51-9060-7169-179B-F541DAFC0C7E}"/>
-              </a:ext>
-            </a:extLst>
-          </p:cNvPr>
-          <p:cNvSpPr>
-            <a:spLocks noGrp="1"/>
-          </p:cNvSpPr>
-          <p:nvPr>
-            <p:ph type="body" sz="quarter" idx="15" hasCustomPrompt="1"/>
-          </p:nvPr>
-        </p:nvSpPr>
-        <p:spPr>
-          <a:xfrm>
-            <a:off x="4266801" y="3807625"/>
-            <a:ext cx="2500255" cy="610343"/>
-          </a:xfrm>
-          <a:prstGeom prst="rect">
-            <a:avLst/>
-          </a:prstGeom>
-        </p:spPr>
-        <p:txBody>
-          <a:bodyPr lIns="0" tIns="0" rIns="0" bIns="0"/>
-          <a:lstStyle>
-            <a:lvl1pPr marL="0" indent="0" algn="l">
               <a:buNone/>
               <a:defRPr sz="1200"/>
             </a:lvl1pPr>
@@ -2617,155 +2449,6 @@
               <a:t>X%</a:t>
             </a:r>
             <a:endParaRPr lang="en-AU" dirty="0"/>
-          </a:p>
-        </p:txBody>
-      </p:sp>
-      <p:sp>
-        <p:nvSpPr>
-          <p:cNvPr id="47" name="ph_ihbl_pct">
-            <a:extLst>
-              <a:ext uri="{FF2B5EF4-FFF2-40B4-BE49-F238E27FC236}">
-                <a16:creationId xmlns:a16="http://schemas.microsoft.com/office/drawing/2014/main" id="{B1F62D07-2195-698B-2714-154E4501E4EB}"/>
-              </a:ext>
-            </a:extLst>
-          </p:cNvPr>
-          <p:cNvSpPr>
-            <a:spLocks noGrp="1"/>
-          </p:cNvSpPr>
-          <p:nvPr>
-            <p:ph type="body" sz="quarter" idx="27" hasCustomPrompt="1"/>
-          </p:nvPr>
-        </p:nvSpPr>
-        <p:spPr>
-          <a:xfrm>
-            <a:off x="5019163" y="3014573"/>
-            <a:ext cx="1516977" cy="504000"/>
-          </a:xfrm>
-          <a:prstGeom prst="rect">
-            <a:avLst/>
-          </a:prstGeom>
-        </p:spPr>
-        <p:txBody>
-          <a:bodyPr lIns="0" tIns="0" rIns="0" bIns="0" anchor="ctr" anchorCtr="0"/>
-          <a:lstStyle>
-            <a:lvl1pPr marL="0" indent="0" algn="l">
-              <a:buNone/>
-              <a:defRPr sz="4800">
-                <a:solidFill>
-                  <a:srgbClr val="133F6D"/>
-                </a:solidFill>
-              </a:defRPr>
-            </a:lvl1pPr>
-            <a:lvl2pPr>
-              <a:defRPr>
-                <a:solidFill>
-                  <a:srgbClr val="133F6D"/>
-                </a:solidFill>
-              </a:defRPr>
-            </a:lvl2pPr>
-            <a:lvl3pPr>
-              <a:defRPr>
-                <a:solidFill>
-                  <a:srgbClr val="133F6D"/>
-                </a:solidFill>
-              </a:defRPr>
-            </a:lvl3pPr>
-            <a:lvl4pPr>
-              <a:defRPr>
-                <a:solidFill>
-                  <a:srgbClr val="133F6D"/>
-                </a:solidFill>
-              </a:defRPr>
-            </a:lvl4pPr>
-            <a:lvl5pPr>
-              <a:defRPr>
-                <a:solidFill>
-                  <a:srgbClr val="133F6D"/>
-                </a:solidFill>
-              </a:defRPr>
-            </a:lvl5pPr>
-          </a:lstStyle>
-          <a:p>
-            <a:pPr lvl="0"/>
-            <a:r>
-              <a:rPr lang="en-US" dirty="0"/>
-              <a:t>X%</a:t>
-            </a:r>
-            <a:endParaRPr lang="en-AU" dirty="0"/>
-          </a:p>
-        </p:txBody>
-      </p:sp>
-      <p:sp>
-        <p:nvSpPr>
-          <p:cNvPr id="48" name="ph_mort30r_pct">
-            <a:extLst>
-              <a:ext uri="{FF2B5EF4-FFF2-40B4-BE49-F238E27FC236}">
-                <a16:creationId xmlns:a16="http://schemas.microsoft.com/office/drawing/2014/main" id="{7BD5F46B-2231-6D01-C514-F696C7DDE546}"/>
-              </a:ext>
-            </a:extLst>
-          </p:cNvPr>
-          <p:cNvSpPr>
-            <a:spLocks noGrp="1"/>
-          </p:cNvSpPr>
-          <p:nvPr>
-            <p:ph type="body" sz="quarter" idx="28" hasCustomPrompt="1"/>
-          </p:nvPr>
-        </p:nvSpPr>
-        <p:spPr>
-          <a:xfrm>
-            <a:off x="5795876" y="5169844"/>
-            <a:ext cx="1003621" cy="504000"/>
-          </a:xfrm>
-          <a:prstGeom prst="rect">
-            <a:avLst/>
-          </a:prstGeom>
-        </p:spPr>
-        <p:txBody>
-          <a:bodyPr lIns="0" tIns="0" rIns="0" bIns="0" anchor="ctr" anchorCtr="0"/>
-          <a:lstStyle>
-            <a:lvl1pPr marL="0" indent="0">
-              <a:buNone/>
-              <a:defRPr sz="4800">
-                <a:solidFill>
-                  <a:srgbClr val="D86ECC"/>
-                </a:solidFill>
-              </a:defRPr>
-            </a:lvl1pPr>
-            <a:lvl2pPr>
-              <a:defRPr>
-                <a:solidFill>
-                  <a:srgbClr val="D86ECC"/>
-                </a:solidFill>
-              </a:defRPr>
-            </a:lvl2pPr>
-            <a:lvl3pPr>
-              <a:defRPr>
-                <a:solidFill>
-                  <a:srgbClr val="D86ECC"/>
-                </a:solidFill>
-              </a:defRPr>
-            </a:lvl3pPr>
-            <a:lvl4pPr>
-              <a:defRPr>
-                <a:solidFill>
-                  <a:srgbClr val="D86ECC"/>
-                </a:solidFill>
-              </a:defRPr>
-            </a:lvl4pPr>
-            <a:lvl5pPr>
-              <a:defRPr>
-                <a:solidFill>
-                  <a:srgbClr val="D86ECC"/>
-                </a:solidFill>
-              </a:defRPr>
-            </a:lvl5pPr>
-          </a:lstStyle>
-          <a:p>
-            <a:pPr lvl="0"/>
-            <a:r>
-              <a:rPr lang="en-AU" dirty="0"/>
-              <a:t>X%</a:t>
-            </a:r>
           </a:p>
         </p:txBody>
       </p:sp>
@@ -3241,12 +2924,360 @@
           </a:p>
         </p:txBody>
       </p:sp>
+      <p:sp>
+        <p:nvSpPr>
+          <p:cNvPr id="2" name="shp_mort">
+            <a:extLst>
+              <a:ext uri="{FF2B5EF4-FFF2-40B4-BE49-F238E27FC236}">
+                <a16:creationId xmlns:a16="http://schemas.microsoft.com/office/drawing/2014/main" id="{3723FF2C-A39E-EB3B-E523-F5FEEC353A1E}"/>
+              </a:ext>
+            </a:extLst>
+          </p:cNvPr>
+          <p:cNvSpPr/>
+          <p:nvPr userDrawn="1"/>
+        </p:nvSpPr>
+        <p:spPr>
+          <a:xfrm>
+            <a:off x="4832549" y="4969171"/>
+            <a:ext cx="900000" cy="900000"/>
+          </a:xfrm>
+          <a:prstGeom prst="ellipse">
+            <a:avLst/>
+          </a:prstGeom>
+          <a:solidFill>
+            <a:schemeClr val="accent5">
+              <a:lumMod val="60000"/>
+              <a:lumOff val="40000"/>
+            </a:schemeClr>
+          </a:solidFill>
+          <a:ln>
+            <a:noFill/>
+          </a:ln>
+        </p:spPr>
+        <p:style>
+          <a:lnRef idx="2">
+            <a:schemeClr val="accent1">
+              <a:shade val="50000"/>
+            </a:schemeClr>
+          </a:lnRef>
+          <a:fillRef idx="1">
+            <a:schemeClr val="accent1"/>
+          </a:fillRef>
+          <a:effectRef idx="0">
+            <a:schemeClr val="accent1"/>
+          </a:effectRef>
+          <a:fontRef idx="minor">
+            <a:schemeClr val="lt1"/>
+          </a:fontRef>
+        </p:style>
+        <p:txBody>
+          <a:bodyPr rtlCol="0" anchor="ctr"/>
+          <a:lstStyle/>
+          <a:p>
+            <a:pPr algn="ctr"/>
+            <a:endParaRPr lang="en-AU" sz="1801" dirty="0">
+              <a:solidFill>
+                <a:schemeClr val="accent1"/>
+              </a:solidFill>
+            </a:endParaRPr>
+          </a:p>
+        </p:txBody>
+      </p:sp>
+      <p:sp>
+        <p:nvSpPr>
+          <p:cNvPr id="3" name="shp_frailty">
+            <a:extLst>
+              <a:ext uri="{FF2B5EF4-FFF2-40B4-BE49-F238E27FC236}">
+                <a16:creationId xmlns:a16="http://schemas.microsoft.com/office/drawing/2014/main" id="{2246FFC7-80A1-92CC-BEE5-482CE5FDFC10}"/>
+              </a:ext>
+            </a:extLst>
+          </p:cNvPr>
+          <p:cNvSpPr/>
+          <p:nvPr userDrawn="1"/>
+        </p:nvSpPr>
+        <p:spPr>
+          <a:xfrm>
+            <a:off x="3911092" y="2786713"/>
+            <a:ext cx="900000" cy="900000"/>
+          </a:xfrm>
+          <a:prstGeom prst="ellipse">
+            <a:avLst/>
+          </a:prstGeom>
+          <a:solidFill>
+            <a:schemeClr val="accent1"/>
+          </a:solidFill>
+          <a:ln>
+            <a:noFill/>
+          </a:ln>
+        </p:spPr>
+        <p:style>
+          <a:lnRef idx="2">
+            <a:schemeClr val="accent1">
+              <a:shade val="50000"/>
+            </a:schemeClr>
+          </a:lnRef>
+          <a:fillRef idx="1">
+            <a:schemeClr val="accent1"/>
+          </a:fillRef>
+          <a:effectRef idx="0">
+            <a:schemeClr val="accent1"/>
+          </a:effectRef>
+          <a:fontRef idx="minor">
+            <a:schemeClr val="lt1"/>
+          </a:fontRef>
+        </p:style>
+        <p:txBody>
+          <a:bodyPr rtlCol="0" anchor="ctr"/>
+          <a:lstStyle/>
+          <a:p>
+            <a:pPr algn="ctr"/>
+            <a:endParaRPr lang="en-AU" sz="1801" dirty="0">
+              <a:solidFill>
+                <a:schemeClr val="accent1"/>
+              </a:solidFill>
+            </a:endParaRPr>
+          </a:p>
+        </p:txBody>
+      </p:sp>
+      <p:sp>
+        <p:nvSpPr>
+          <p:cNvPr id="4" name="ph_radial">
+            <a:extLst>
+              <a:ext uri="{FF2B5EF4-FFF2-40B4-BE49-F238E27FC236}">
+                <a16:creationId xmlns:a16="http://schemas.microsoft.com/office/drawing/2014/main" id="{9F27922F-9508-784E-406B-7DCCD5C252DB}"/>
+              </a:ext>
+            </a:extLst>
+          </p:cNvPr>
+          <p:cNvSpPr>
+            <a:spLocks noGrp="1"/>
+          </p:cNvSpPr>
+          <p:nvPr>
+            <p:ph type="body" sz="quarter" idx="12" hasCustomPrompt="1"/>
+          </p:nvPr>
+        </p:nvSpPr>
+        <p:spPr>
+          <a:xfrm>
+            <a:off x="4986852" y="5997264"/>
+            <a:ext cx="1839649" cy="620712"/>
+          </a:xfrm>
+          <a:prstGeom prst="rect">
+            <a:avLst/>
+          </a:prstGeom>
+        </p:spPr>
+        <p:txBody>
+          <a:bodyPr lIns="0" tIns="0" rIns="0" bIns="0"/>
+          <a:lstStyle>
+            <a:lvl1pPr marL="0" indent="0">
+              <a:buNone/>
+              <a:defRPr sz="1600"/>
+            </a:lvl1pPr>
+          </a:lstStyle>
+          <a:p>
+            <a:pPr lvl="0"/>
+            <a:r>
+              <a:rPr lang="en-AU" dirty="0"/>
+              <a:t>Template text here</a:t>
+            </a:r>
+          </a:p>
+        </p:txBody>
+      </p:sp>
+      <p:sp>
+        <p:nvSpPr>
+          <p:cNvPr id="5" name="ph_stemi">
+            <a:extLst>
+              <a:ext uri="{FF2B5EF4-FFF2-40B4-BE49-F238E27FC236}">
+                <a16:creationId xmlns:a16="http://schemas.microsoft.com/office/drawing/2014/main" id="{C94EBEE4-289A-3C4E-B519-3FDD1D2DDD37}"/>
+              </a:ext>
+            </a:extLst>
+          </p:cNvPr>
+          <p:cNvSpPr>
+            <a:spLocks noGrp="1"/>
+          </p:cNvSpPr>
+          <p:nvPr>
+            <p:ph type="body" sz="quarter" idx="15" hasCustomPrompt="1"/>
+          </p:nvPr>
+        </p:nvSpPr>
+        <p:spPr>
+          <a:xfrm>
+            <a:off x="4266801" y="3807625"/>
+            <a:ext cx="2500255" cy="610343"/>
+          </a:xfrm>
+          <a:prstGeom prst="rect">
+            <a:avLst/>
+          </a:prstGeom>
+        </p:spPr>
+        <p:txBody>
+          <a:bodyPr lIns="0" tIns="0" rIns="0" bIns="0"/>
+          <a:lstStyle>
+            <a:lvl1pPr marL="0" indent="0" algn="l">
+              <a:buNone/>
+              <a:defRPr sz="1600"/>
+            </a:lvl1pPr>
+          </a:lstStyle>
+          <a:p>
+            <a:pPr lvl="0"/>
+            <a:r>
+              <a:rPr lang="en-AU" dirty="0"/>
+              <a:t>Template text here</a:t>
+            </a:r>
+          </a:p>
+        </p:txBody>
+      </p:sp>
+      <p:sp>
+        <p:nvSpPr>
+          <p:cNvPr id="6" name="ph_stemi_pct">
+            <a:extLst>
+              <a:ext uri="{FF2B5EF4-FFF2-40B4-BE49-F238E27FC236}">
+                <a16:creationId xmlns:a16="http://schemas.microsoft.com/office/drawing/2014/main" id="{4E071649-D758-D48B-C624-DB7B23572563}"/>
+              </a:ext>
+            </a:extLst>
+          </p:cNvPr>
+          <p:cNvSpPr>
+            <a:spLocks noGrp="1"/>
+          </p:cNvSpPr>
+          <p:nvPr>
+            <p:ph type="body" sz="quarter" idx="27" hasCustomPrompt="1"/>
+          </p:nvPr>
+        </p:nvSpPr>
+        <p:spPr>
+          <a:xfrm>
+            <a:off x="5019163" y="3014573"/>
+            <a:ext cx="1516977" cy="504000"/>
+          </a:xfrm>
+          <a:prstGeom prst="rect">
+            <a:avLst/>
+          </a:prstGeom>
+        </p:spPr>
+        <p:txBody>
+          <a:bodyPr lIns="0" tIns="0" rIns="0" bIns="0" anchor="ctr" anchorCtr="0"/>
+          <a:lstStyle>
+            <a:lvl1pPr marL="0" indent="0" algn="l">
+              <a:buNone/>
+              <a:defRPr sz="4800">
+                <a:solidFill>
+                  <a:srgbClr val="133F6D"/>
+                </a:solidFill>
+              </a:defRPr>
+            </a:lvl1pPr>
+            <a:lvl2pPr>
+              <a:defRPr>
+                <a:solidFill>
+                  <a:srgbClr val="133F6D"/>
+                </a:solidFill>
+              </a:defRPr>
+            </a:lvl2pPr>
+            <a:lvl3pPr>
+              <a:defRPr>
+                <a:solidFill>
+                  <a:srgbClr val="133F6D"/>
+                </a:solidFill>
+              </a:defRPr>
+            </a:lvl3pPr>
+            <a:lvl4pPr>
+              <a:defRPr>
+                <a:solidFill>
+                  <a:srgbClr val="133F6D"/>
+                </a:solidFill>
+              </a:defRPr>
+            </a:lvl4pPr>
+            <a:lvl5pPr>
+              <a:defRPr>
+                <a:solidFill>
+                  <a:srgbClr val="133F6D"/>
+                </a:solidFill>
+              </a:defRPr>
+            </a:lvl5pPr>
+          </a:lstStyle>
+          <a:p>
+            <a:pPr lvl="0"/>
+            <a:r>
+              <a:rPr lang="en-US" dirty="0"/>
+              <a:t>X%</a:t>
+            </a:r>
+            <a:endParaRPr lang="en-AU" dirty="0"/>
+          </a:p>
+        </p:txBody>
+      </p:sp>
+      <p:sp>
+        <p:nvSpPr>
+          <p:cNvPr id="7" name="ph_radial_pct">
+            <a:extLst>
+              <a:ext uri="{FF2B5EF4-FFF2-40B4-BE49-F238E27FC236}">
+                <a16:creationId xmlns:a16="http://schemas.microsoft.com/office/drawing/2014/main" id="{4B8B6ACB-7AEF-38A5-D862-D034A79C91D7}"/>
+              </a:ext>
+            </a:extLst>
+          </p:cNvPr>
+          <p:cNvSpPr>
+            <a:spLocks noGrp="1"/>
+          </p:cNvSpPr>
+          <p:nvPr>
+            <p:ph type="body" sz="quarter" idx="28" hasCustomPrompt="1"/>
+          </p:nvPr>
+        </p:nvSpPr>
+        <p:spPr>
+          <a:xfrm>
+            <a:off x="5795876" y="5169844"/>
+            <a:ext cx="1003621" cy="504000"/>
+          </a:xfrm>
+          <a:prstGeom prst="rect">
+            <a:avLst/>
+          </a:prstGeom>
+        </p:spPr>
+        <p:txBody>
+          <a:bodyPr lIns="0" tIns="0" rIns="0" bIns="0" anchor="ctr" anchorCtr="0"/>
+          <a:lstStyle>
+            <a:lvl1pPr marL="0" indent="0">
+              <a:buNone/>
+              <a:defRPr sz="4800">
+                <a:solidFill>
+                  <a:srgbClr val="D86ECC"/>
+                </a:solidFill>
+              </a:defRPr>
+            </a:lvl1pPr>
+            <a:lvl2pPr>
+              <a:defRPr>
+                <a:solidFill>
+                  <a:srgbClr val="D86ECC"/>
+                </a:solidFill>
+              </a:defRPr>
+            </a:lvl2pPr>
+            <a:lvl3pPr>
+              <a:defRPr>
+                <a:solidFill>
+                  <a:srgbClr val="D86ECC"/>
+                </a:solidFill>
+              </a:defRPr>
+            </a:lvl3pPr>
+            <a:lvl4pPr>
+              <a:defRPr>
+                <a:solidFill>
+                  <a:srgbClr val="D86ECC"/>
+                </a:solidFill>
+              </a:defRPr>
+            </a:lvl4pPr>
+            <a:lvl5pPr>
+              <a:defRPr>
+                <a:solidFill>
+                  <a:srgbClr val="D86ECC"/>
+                </a:solidFill>
+              </a:defRPr>
+            </a:lvl5pPr>
+          </a:lstStyle>
+          <a:p>
+            <a:pPr lvl="0"/>
+            <a:r>
+              <a:rPr lang="en-AU" dirty="0"/>
+              <a:t>X%</a:t>
+            </a:r>
+          </a:p>
+        </p:txBody>
+      </p:sp>
       <p:pic>
         <p:nvPicPr>
-          <p:cNvPr id="94" name="Picture 93">
+          <p:cNvPr id="8" name="icon_radial">
             <a:extLst>
               <a:ext uri="{FF2B5EF4-FFF2-40B4-BE49-F238E27FC236}">
-                <a16:creationId xmlns:a16="http://schemas.microsoft.com/office/drawing/2014/main" id="{6C1D9F35-E879-69FC-7F97-6A6DA195BB72}"/>
+                <a16:creationId xmlns:a16="http://schemas.microsoft.com/office/drawing/2014/main" id="{239833F4-E882-925C-420D-3DBF69AA6AED}"/>
               </a:ext>
             </a:extLst>
           </p:cNvPr>
@@ -3256,21 +3287,84 @@
           <p:nvPr userDrawn="1"/>
         </p:nvPicPr>
         <p:blipFill>
-          <a:blip r:embed="rId11" cstate="print">
+          <a:blip r:embed="rId10">
+            <a:clrChange>
+              <a:clrFrom>
+                <a:srgbClr val="000000"/>
+              </a:clrFrom>
+              <a:clrTo>
+                <a:srgbClr val="000000">
+                  <a:alpha val="0"/>
+                </a:srgbClr>
+              </a:clrTo>
+            </a:clrChange>
             <a:extLst>
-              <a:ext uri="{28A0092B-C50C-407E-A947-70E740481C1C}">
-                <a14:useLocalDpi xmlns:a14="http://schemas.microsoft.com/office/drawing/2010/main"/>
+              <a:ext uri="{BEBA8EAE-BF5A-486C-A8C5-ECC9F3942E4B}">
+                <a14:imgProps xmlns:a14="http://schemas.microsoft.com/office/drawing/2010/main">
+                  <a14:imgLayer r:embed="rId11">
+                    <a14:imgEffect>
+                      <a14:backgroundRemoval t="10000" b="90000" l="10000" r="90000">
+                        <a14:foregroundMark x1="42383" y1="45117" x2="42383" y2="45117"/>
+                        <a14:foregroundMark x1="44141" y1="45605" x2="44141" y2="45605"/>
+                        <a14:foregroundMark x1="46777" y1="45703" x2="46777" y2="45703"/>
+                        <a14:foregroundMark x1="52734" y1="45996" x2="52734" y2="45996"/>
+                        <a14:foregroundMark x1="54492" y1="45996" x2="54492" y2="45996"/>
+                        <a14:foregroundMark x1="49805" y1="49121" x2="49805" y2="49121"/>
+                        <a14:foregroundMark x1="56738" y1="45605" x2="56738" y2="45605"/>
+                        <a14:foregroundMark x1="58887" y1="45996" x2="58887" y2="45996"/>
+                        <a14:foregroundMark x1="60547" y1="45801" x2="60547" y2="45801"/>
+                        <a14:foregroundMark x1="62988" y1="45996" x2="62988" y2="45996"/>
+                        <a14:foregroundMark x1="65723" y1="46191" x2="65723" y2="46191"/>
+                        <a14:foregroundMark x1="67188" y1="46191" x2="67188" y2="46191"/>
+                        <a14:foregroundMark x1="69336" y1="46094" x2="69336" y2="46094"/>
+                        <a14:foregroundMark x1="71875" y1="45996" x2="71875" y2="45996"/>
+                        <a14:foregroundMark x1="73730" y1="46582" x2="73730" y2="46582"/>
+                        <a14:foregroundMark x1="75684" y1="46777" x2="75684" y2="46777"/>
+                        <a14:foregroundMark x1="77637" y1="47656" x2="77637" y2="47656"/>
+                      </a14:backgroundRemoval>
+                    </a14:imgEffect>
+                  </a14:imgLayer>
+                </a14:imgProps>
               </a:ext>
             </a:extLst>
           </a:blip>
+          <a:srcRect l="9320" t="28301" r="45829" b="33282"/>
+          <a:stretch/>
+        </p:blipFill>
+        <p:spPr>
+          <a:xfrm rot="1623292">
+            <a:off x="4873079" y="5011030"/>
+            <a:ext cx="848642" cy="726915"/>
+          </a:xfrm>
+          <a:prstGeom prst="rect">
+            <a:avLst/>
+          </a:prstGeom>
+        </p:spPr>
+      </p:pic>
+      <p:pic>
+        <p:nvPicPr>
+          <p:cNvPr id="9" name="pic_stemi">
+            <a:extLst>
+              <a:ext uri="{FF2B5EF4-FFF2-40B4-BE49-F238E27FC236}">
+                <a16:creationId xmlns:a16="http://schemas.microsoft.com/office/drawing/2014/main" id="{82F6D077-AF86-CA97-756B-17452826BF08}"/>
+              </a:ext>
+            </a:extLst>
+          </p:cNvPr>
+          <p:cNvPicPr>
+            <a:picLocks noChangeAspect="1"/>
+          </p:cNvPicPr>
+          <p:nvPr userDrawn="1"/>
+        </p:nvPicPr>
+        <p:blipFill>
+          <a:blip r:embed="rId12"/>
           <a:stretch>
             <a:fillRect/>
           </a:stretch>
         </p:blipFill>
         <p:spPr>
           <a:xfrm>
-            <a:off x="4164763" y="2856820"/>
-            <a:ext cx="406626" cy="664426"/>
+            <a:off x="3804989" y="2621587"/>
+            <a:ext cx="1138003" cy="1138003"/>
           </a:xfrm>
           <a:prstGeom prst="rect">
             <a:avLst/>
@@ -3537,7 +3631,7 @@
         </p:nvSpPr>
         <p:spPr>
           <a:xfrm>
-            <a:off x="3249481" y="668709"/>
+            <a:off x="3521335" y="520425"/>
             <a:ext cx="1132840" cy="457200"/>
           </a:xfrm>
           <a:custGeom>
@@ -5110,7 +5204,7 @@
         </p:nvGrpSpPr>
         <p:grpSpPr>
           <a:xfrm>
-            <a:off x="2178281" y="299438"/>
+            <a:off x="2450135" y="151154"/>
             <a:ext cx="974356" cy="1148737"/>
             <a:chOff x="0" y="0"/>
             <a:chExt cx="852169" cy="1004569"/>
@@ -7230,7 +7324,7 @@
             <a:spLocks noGrp="1"/>
           </p:cNvSpPr>
           <p:nvPr>
-            <p:ph type="body" sz="quarter" idx="15" hasCustomPrompt="1"/>
+            <p:ph type="body" sz="quarter" idx="4294967295" hasCustomPrompt="1"/>
           </p:nvPr>
         </p:nvSpPr>
         <p:spPr>
@@ -7238,14 +7332,22 @@
             <a:off x="4266801" y="3807625"/>
             <a:ext cx="2500255" cy="610343"/>
           </a:xfrm>
+          <a:prstGeom prst="rect">
+            <a:avLst/>
+          </a:prstGeom>
         </p:spPr>
         <p:txBody>
           <a:bodyPr/>
           <a:lstStyle/>
           <a:p>
+            <a:pPr marL="0" indent="0">
+              <a:buNone/>
+            </a:pPr>
             <a:r>
-              <a:t>2 out of 119 patients In-hospital major bleeding</a:t>
+              <a:rPr lang="en-AU" sz="1200" dirty="0"/>
+              <a:t>Proportion of patient undergoing procedure (example)</a:t>
             </a:r>
+            <a:endParaRPr sz="1200" dirty="0"/>
           </a:p>
         </p:txBody>
       </p:sp>
@@ -7256,7 +7358,7 @@
             <a:spLocks noGrp="1"/>
           </p:cNvSpPr>
           <p:nvPr>
-            <p:ph type="body" sz="quarter" idx="27" hasCustomPrompt="1"/>
+            <p:ph type="body" sz="quarter" idx="4294967295" hasCustomPrompt="1"/>
           </p:nvPr>
         </p:nvSpPr>
         <p:spPr>
@@ -7264,12 +7366,23 @@
             <a:off x="5019163" y="3014573"/>
             <a:ext cx="1516977" cy="504000"/>
           </a:xfrm>
+          <a:prstGeom prst="rect">
+            <a:avLst/>
+          </a:prstGeom>
         </p:spPr>
         <p:txBody>
           <a:bodyPr/>
           <a:lstStyle/>
           <a:p>
+            <a:pPr marL="0" indent="0">
+              <a:buNone/>
+            </a:pPr>
             <a:r>
+              <a:rPr sz="3200" dirty="0">
+                <a:solidFill>
+                  <a:srgbClr val="156082"/>
+                </a:solidFill>
+              </a:rPr>
               <a:t>2%</a:t>
             </a:r>
           </a:p>
@@ -7334,7 +7447,7 @@
             <a:spLocks noGrp="1"/>
           </p:cNvSpPr>
           <p:nvPr>
-            <p:ph type="body" sz="quarter" idx="12" hasCustomPrompt="1"/>
+            <p:ph type="body" sz="quarter" idx="4294967295" hasCustomPrompt="1"/>
           </p:nvPr>
         </p:nvSpPr>
         <p:spPr>
@@ -7342,14 +7455,22 @@
             <a:off x="4949781" y="5997264"/>
             <a:ext cx="1839649" cy="620712"/>
           </a:xfrm>
+          <a:prstGeom prst="rect">
+            <a:avLst/>
+          </a:prstGeom>
         </p:spPr>
         <p:txBody>
           <a:bodyPr/>
           <a:lstStyle/>
           <a:p>
+            <a:pPr marL="0" indent="0">
+              <a:buNone/>
+            </a:pPr>
             <a:r>
-              <a:t>10 out of 311 patients 30 day mortality after PCI</a:t>
+              <a:rPr lang="en-AU" sz="1200" dirty="0"/>
+              <a:t>Example indicator for exemplar measure (data pending)</a:t>
             </a:r>
+            <a:endParaRPr sz="1200" dirty="0"/>
           </a:p>
         </p:txBody>
       </p:sp>
@@ -7360,7 +7481,7 @@
             <a:spLocks noGrp="1"/>
           </p:cNvSpPr>
           <p:nvPr>
-            <p:ph type="body" sz="quarter" idx="28" hasCustomPrompt="1"/>
+            <p:ph type="body" sz="quarter" idx="4294967295" hasCustomPrompt="1"/>
           </p:nvPr>
         </p:nvSpPr>
         <p:spPr>
@@ -7368,12 +7489,23 @@
             <a:off x="5795876" y="5169844"/>
             <a:ext cx="1003621" cy="504000"/>
           </a:xfrm>
+          <a:prstGeom prst="rect">
+            <a:avLst/>
+          </a:prstGeom>
         </p:spPr>
         <p:txBody>
           <a:bodyPr/>
           <a:lstStyle/>
           <a:p>
+            <a:pPr marL="0" indent="0">
+              <a:buNone/>
+            </a:pPr>
             <a:r>
+              <a:rPr sz="2800" dirty="0">
+                <a:solidFill>
+                  <a:srgbClr val="D86ECC"/>
+                </a:solidFill>
+              </a:rPr>
               <a:t>3%</a:t>
             </a:r>
           </a:p>
@@ -7426,6 +7558,7 @@
           <a:lstStyle/>
           <a:p>
             <a:r>
+              <a:rPr dirty="0"/>
               <a:t>610 procedures were undertaken</a:t>
             </a:r>
           </a:p>
@@ -7495,7 +7628,7 @@
         </p:blipFill>
         <p:spPr>
           <a:xfrm>
-            <a:off x="4778375" y="354013"/>
+            <a:off x="4778375" y="32737"/>
             <a:ext cx="1800225" cy="1800225"/>
           </a:xfrm>
           <a:prstGeom prst="rect">

</xml_diff>